<commit_message>
Derive asymmetric columns from native template layouts
</commit_message>
<xml_diff>
--- a/templates/abstract.pptx
+++ b/templates/abstract.pptx
@@ -2127,7 +2127,7 @@
         <p:spPr>
           <a:xfrm>
             <a:off x="838200" y="1825625"/>
-            <a:ext cx="5181600" cy="4351338"/>
+            <a:ext cx="5120640" cy="4351338"/>
           </a:xfrm>
         </p:spPr>
         <p:txBody>
@@ -2180,8 +2180,8 @@
         </p:nvSpPr>
         <p:spPr>
           <a:xfrm>
-            <a:off x="6172200" y="1825625"/>
-            <a:ext cx="5181600" cy="4351338"/>
+            <a:off x="6233160" y="1825625"/>
+            <a:ext cx="5120640" cy="4351338"/>
           </a:xfrm>
         </p:spPr>
         <p:txBody>

</xml_diff>

<commit_message>
fix: preserve native text styles and stabilize render test startup
</commit_message>
<xml_diff>
--- a/templates/abstract.pptx
+++ b/templates/abstract.pptx
@@ -1737,7 +1737,7 @@
           <a:p>
             <a:r>
               <a:rPr lang="en-US" dirty="0"/>
-              <a:t>PRESENTATION TITLE</a:t>
+              <a:t/>
             </a:r>
           </a:p>
         </p:txBody>
@@ -2012,7 +2012,7 @@
           <a:p>
             <a:r>
               <a:rPr lang="en-US" dirty="0"/>
-              <a:t>PRESENTATION TITLE</a:t>
+              <a:t/>
             </a:r>
           </a:p>
         </p:txBody>
@@ -2521,7 +2521,7 @@
           <a:p>
             <a:r>
               <a:rPr lang="en-US" dirty="0"/>
-              <a:t>PRESENTATION TITLE</a:t>
+              <a:t/>
             </a:r>
           </a:p>
         </p:txBody>

</xml_diff>